<commit_message>
Rename STRATUS -> Falda across whitepaper, READMEs, deck generator + deck
- Whitepaper 'TDAI, Falda, UMP'; repo URLs -> rick-stevens-ai/falda
- tdai/build_deck.py: Falda = go-forward primary, TDAI = predecessor
  being migrated from (drop 'shadow' framing); deck regenerated (16 slides)
- Old STRATUS decks archived under _archive/stratus-prerename-20260627/
- 0 stratus refs outside _archive
</commit_message>
<xml_diff>
--- a/decks/tdai-memory-system.pptx
+++ b/decks/tdai-memory-system.pptx
@@ -3384,7 +3384,7 @@
                 </a:solidFill>
                 <a:latin typeface="Calibri"/>
               </a:rPr>
-              <a:t>(TDAI · STRATUS · UMP)   </a:t>
+              <a:t>(TDAI → Falda · UMP)   </a:t>
             </a:r>
             <a:r>
               <a:rPr sz="1700" b="1" i="0">
@@ -4157,7 +4157,7 @@
                 </a:solidFill>
                 <a:latin typeface="Consolas"/>
               </a:rPr>
-              <a:t>Agent memory + cross-agent stack · TDAI / STRATUS · Sibline · UMP</a:t>
+              <a:t>Agent memory + cross-agent stack · TDAI / Falda · Sibline · UMP</a:t>
             </a:r>
           </a:p>
         </p:txBody>
@@ -5315,7 +5315,7 @@
                 </a:solidFill>
                 <a:latin typeface="Consolas"/>
               </a:rPr>
-              <a:t>Agent memory + cross-agent stack · TDAI / STRATUS · Sibline · UMP</a:t>
+              <a:t>Agent memory + cross-agent stack · TDAI / Falda · Sibline · UMP</a:t>
             </a:r>
           </a:p>
         </p:txBody>
@@ -5977,7 +5977,7 @@
                 </a:solidFill>
                 <a:latin typeface="Consolas"/>
               </a:rPr>
-              <a:t>Agent memory + cross-agent stack · TDAI / STRATUS · Sibline · UMP</a:t>
+              <a:t>Agent memory + cross-agent stack · TDAI / Falda · Sibline · UMP</a:t>
             </a:r>
           </a:p>
         </p:txBody>
@@ -6152,7 +6152,7 @@
                 </a:solidFill>
                 <a:latin typeface="Calibri"/>
               </a:rPr>
-              <a:t>Plugging a harness into STRATUS</a:t>
+              <a:t>Plugging a harness into Falda</a:t>
             </a:r>
           </a:p>
         </p:txBody>
@@ -6503,7 +6503,7 @@
                 </a:solidFill>
                 <a:latin typeface="Consolas"/>
               </a:rPr>
-              <a:t>L0 → /stream/add</a:t>
+              <a:t>T0 → /stream/add</a:t>
             </a:r>
           </a:p>
         </p:txBody>
@@ -6696,7 +6696,7 @@
                 </a:solidFill>
                 <a:latin typeface="Consolas"/>
               </a:rPr>
-              <a:t>STRATUS :8077</a:t>
+              <a:t>Falda :8077</a:t>
             </a:r>
           </a:p>
         </p:txBody>
@@ -7047,8 +7047,8 @@
                 </a:solidFill>
                 <a:latin typeface="Calibri"/>
               </a:rPr>
-              <a:t>SHADOW — tap captures + validates, NOT in recall path (safe dual-run)
-LIVE — STRATUS becomes the memory provider (one config flip)</a:t>
+              <a:t>DUAL-RUN — tap captures + validates alongside TDAI during cutover
+PRIMARY — Falda is the memory provider (one config flip away)</a:t>
             </a:r>
           </a:p>
         </p:txBody>
@@ -7242,7 +7242,7 @@
                 </a:solidFill>
                 <a:latin typeface="Consolas"/>
               </a:rPr>
-              <a:t>Agent memory + cross-agent stack · TDAI / STRATUS · Sibline · UMP</a:t>
+              <a:t>Agent memory + cross-agent stack · TDAI / Falda · Sibline · UMP</a:t>
             </a:r>
           </a:p>
         </p:txBody>
@@ -7544,7 +7544,7 @@
                 </a:solidFill>
                 <a:latin typeface="Consolas"/>
               </a:rPr>
-              <a:t>stratus/</a:t>
+              <a:t>falda/</a:t>
             </a:r>
           </a:p>
           <a:p>
@@ -7656,7 +7656,7 @@
                 </a:solidFill>
                 <a:latin typeface="Consolas"/>
               </a:rPr>
-              <a:t>    com.example.stratus-gateway.template</a:t>
+              <a:t>    com.example.falda-gateway.template</a:t>
             </a:r>
           </a:p>
           <a:p>
@@ -7672,7 +7672,7 @@
                 </a:solidFill>
                 <a:latin typeface="Consolas"/>
               </a:rPr>
-              <a:t>    com.example.stratus-tap-openclaw.template</a:t>
+              <a:t>    com.example.falda-tap-openclaw.template</a:t>
             </a:r>
           </a:p>
           <a:p>
@@ -7879,7 +7879,7 @@
                 </a:solidFill>
                 <a:latin typeface="Consolas"/>
               </a:rPr>
-              <a:t>Agent memory + cross-agent stack · TDAI / STRATUS · Sibline · UMP</a:t>
+              <a:t>Agent memory + cross-agent stack · TDAI / Falda · Sibline · UMP</a:t>
             </a:r>
           </a:p>
         </p:txBody>
@@ -8212,7 +8212,7 @@
                 </a:solidFill>
                 <a:latin typeface="Calibri"/>
               </a:rPr>
-              <a:t>STRATUS gateway /healthz</a:t>
+              <a:t>Falda gateway /healthz</a:t>
             </a:r>
           </a:p>
         </p:txBody>
@@ -9247,7 +9247,7 @@
                 </a:solidFill>
                 <a:latin typeface="Consolas"/>
               </a:rPr>
-              <a:t>Agent memory + cross-agent stack · TDAI / STRATUS · Sibline · UMP</a:t>
+              <a:t>Agent memory + cross-agent stack · TDAI / Falda · Sibline · UMP</a:t>
             </a:r>
           </a:p>
         </p:txBody>
@@ -9470,7 +9470,7 @@
                 </a:solidFill>
                 <a:latin typeface="Calibri"/>
               </a:rPr>
-              <a:t>•  TDAI — live four-layer (L0→L3) memory with auto-recall; authoritative today.</a:t>
+              <a:t>•  Falda — born-clean US-origin four-tier (T0→T3) engine becoming the primary memory provider.</a:t>
             </a:r>
           </a:p>
           <a:p>
@@ -9486,7 +9486,7 @@
                 </a:solidFill>
                 <a:latin typeface="Calibri"/>
               </a:rPr>
-              <a:t>•  STRATUS — born-clean US rebuild (T0→T3), runs shadow, Ollie-maintained.</a:t>
+              <a:t>•  TDAI — the legacy four-layer (L0→L3) runtime being migrated from; same tier semantics, clean handoff.</a:t>
             </a:r>
           </a:p>
           <a:p>
@@ -9581,7 +9581,7 @@
                 </a:solidFill>
                 <a:latin typeface="Consolas"/>
               </a:rPr>
-              <a:t>Agent memory + cross-agent stack · TDAI / STRATUS · Sibline · UMP</a:t>
+              <a:t>Agent memory + cross-agent stack · TDAI / Falda · Sibline · UMP</a:t>
             </a:r>
           </a:p>
         </p:txBody>
@@ -9914,7 +9914,7 @@
                 </a:solidFill>
                 <a:latin typeface="Calibri"/>
               </a:rPr>
-              <a:t>Layered per-agent memory (L0→L3). TDAI is live &amp; authoritative; STRATUS is the clean US rebuild running shadow. UMP + vault hold shared facts.</a:t>
+              <a:t>Layered per-agent memory (T0→T3). Falda is the born-clean US-origin four-tier engine becoming the primary, migrated from the older TDAI runtime. UMP + vault hold shared facts.</a:t>
             </a:r>
           </a:p>
         </p:txBody>
@@ -10230,7 +10230,7 @@
                 </a:solidFill>
                 <a:latin typeface="Calibri"/>
               </a:rPr>
-              <a:t>A documented, replication-grade recipe plugs either harness (Hermes / OpenClaw) into STRATUS — stand it up + verify from scratch.</a:t>
+              <a:t>A documented, replication-grade recipe plugs either harness (Hermes / OpenClaw) into Falda — stand it up + verify from scratch.</a:t>
             </a:r>
           </a:p>
         </p:txBody>
@@ -10309,7 +10309,7 @@
                 </a:solidFill>
                 <a:latin typeface="Consolas"/>
               </a:rPr>
-              <a:t>Agent memory + cross-agent stack · TDAI / STRATUS · Sibline · UMP</a:t>
+              <a:t>Agent memory + cross-agent stack · TDAI / Falda · Sibline · UMP</a:t>
             </a:r>
           </a:p>
         </p:txBody>
@@ -10805,7 +10805,7 @@
               </a:rPr>
               <a:t>Harness: OpenClaw (Node/TS)
 Host: CherryRd
-Runs STRATUS gateway + tap
+Runs Falda gateway + tap
 @RickOllie_bot</a:t>
             </a:r>
           </a:p>
@@ -10964,7 +10964,7 @@
                 </a:solidFill>
                 <a:latin typeface="Consolas"/>
               </a:rPr>
-              <a:t>Agent memory + cross-agent stack · TDAI / STRATUS · Sibline · UMP</a:t>
+              <a:t>Agent memory + cross-agent stack · TDAI / Falda · Sibline · UMP</a:t>
             </a:r>
           </a:p>
         </p:txBody>
@@ -11973,7 +11973,7 @@
                 </a:solidFill>
                 <a:latin typeface="Calibri"/>
               </a:rPr>
-              <a:t>TDAI  (L0→L3)</a:t>
+              <a:t>Falda  (T0→T3)</a:t>
             </a:r>
           </a:p>
         </p:txBody>
@@ -12008,7 +12008,7 @@
                 </a:solidFill>
                 <a:latin typeface="Calibri"/>
               </a:rPr>
-              <a:t>the live system — injects context every turn</a:t>
+              <a:t>born-clean US four-tier engine — becoming primary</a:t>
             </a:r>
           </a:p>
         </p:txBody>
@@ -12087,7 +12087,7 @@
                 </a:solidFill>
                 <a:latin typeface="Calibri"/>
               </a:rPr>
-              <a:t>AUTHORITATIVE</a:t>
+              <a:t>PRIMARY</a:t>
             </a:r>
           </a:p>
         </p:txBody>
@@ -12210,7 +12210,7 @@
                 </a:solidFill>
                 <a:latin typeface="Calibri"/>
               </a:rPr>
-              <a:t>STRATUS  (T0→T3)</a:t>
+              <a:t>TDAI  (L0→L3)</a:t>
             </a:r>
           </a:p>
         </p:txBody>
@@ -12245,7 +12245,7 @@
                 </a:solidFill>
                 <a:latin typeface="Calibri"/>
               </a:rPr>
-              <a:t>born-clean US rebuild of TDAI — captures only</a:t>
+              <a:t>legacy live runtime — migrating from</a:t>
             </a:r>
           </a:p>
         </p:txBody>
@@ -12324,7 +12324,7 @@
                 </a:solidFill>
                 <a:latin typeface="Calibri"/>
               </a:rPr>
-              <a:t>SHADOW</a:t>
+              <a:t>RETIRING</a:t>
             </a:r>
           </a:p>
         </p:txBody>
@@ -12359,7 +12359,7 @@
                 </a:solidFill>
                 <a:latin typeface="Consolas"/>
               </a:rPr>
-              <a:t>Agent memory + cross-agent stack · TDAI / STRATUS · Sibline · UMP</a:t>
+              <a:t>Agent memory + cross-agent stack · TDAI / Falda · Sibline · UMP</a:t>
             </a:r>
           </a:p>
         </p:txBody>
@@ -12455,7 +12455,7 @@
                 </a:solidFill>
                 <a:latin typeface="Consolas"/>
               </a:rPr>
-              <a:t>MEMORY · TDAI</a:t>
+              <a:t>MEMORY · TDAI (LEGACY)</a:t>
             </a:r>
           </a:p>
         </p:txBody>
@@ -12534,7 +12534,7 @@
                 </a:solidFill>
                 <a:latin typeface="Calibri"/>
               </a:rPr>
-              <a:t>TDAI: the four-layer pipeline (live)</a:t>
+              <a:t>TDAI: the four-layer pipeline (migrating from)</a:t>
             </a:r>
           </a:p>
         </p:txBody>
@@ -13468,7 +13468,7 @@
                 </a:solidFill>
                 <a:latin typeface="Calibri"/>
               </a:rPr>
-              <a:t>Authoritative today</a:t>
+              <a:t>The reference design</a:t>
             </a:r>
             <a:r>
               <a:rPr sz="1600" b="0" i="0">
@@ -13477,7 +13477,7 @@
                 </a:solidFill>
                 <a:latin typeface="Calibri"/>
               </a:rPr>
-              <a:t> — it injects the right memory into every turn.</a:t>
+              <a:t> — the Falda engine inherits its tier model and ships the go-forward implementation.</a:t>
             </a:r>
           </a:p>
         </p:txBody>
@@ -13512,7 +13512,7 @@
                 </a:solidFill>
                 <a:latin typeface="Consolas"/>
               </a:rPr>
-              <a:t>Agent memory + cross-agent stack · TDAI / STRATUS · Sibline · UMP</a:t>
+              <a:t>Agent memory + cross-agent stack · TDAI / Falda · Sibline · UMP</a:t>
             </a:r>
           </a:p>
         </p:txBody>
@@ -13604,11 +13604,11 @@
             <a:r>
               <a:rPr sz="1400" b="1" i="0">
                 <a:solidFill>
-                  <a:srgbClr val="E08A3C"/>
+                  <a:srgbClr val="5BC88A"/>
                 </a:solidFill>
                 <a:latin typeface="Consolas"/>
               </a:rPr>
-              <a:t>MEMORY · STRATUS</a:t>
+              <a:t>MEMORY · FALDA</a:t>
             </a:r>
           </a:p>
         </p:txBody>
@@ -13628,7 +13628,7 @@
             <a:avLst/>
           </a:prstGeom>
           <a:solidFill>
-            <a:srgbClr val="E08A3C"/>
+            <a:srgbClr val="5BC88A"/>
           </a:solidFill>
           <a:ln>
             <a:noFill/>
@@ -13687,7 +13687,7 @@
                 </a:solidFill>
                 <a:latin typeface="Calibri"/>
               </a:rPr>
-              <a:t>STRATUS: the born-clean US rebuild</a:t>
+              <a:t>Falda: the born-clean US-origin engine</a:t>
             </a:r>
           </a:p>
         </p:txBody>
@@ -13845,10 +13845,10 @@
                 </a:solidFill>
                 <a:latin typeface="Calibri"/>
               </a:rPr>
-              <a:t>Apache-2.0 rewrite of TDAI (T0→T3 = L0→L3).
+              <a:t>Apache-2.0, US-origin reimplementation of the four-tier model (T0→T3 = Stream / Atoms / Scenes / Core).
 better-sqlite3 + sqlite-vec + FTS5.
 HTTP gateway on :8077.
-Ollie maintains the repo.</a:t>
+Public repo: github.com/rick-stevens-ai/falda.</a:t>
             </a:r>
           </a:p>
         </p:txBody>
@@ -13912,7 +13912,7 @@
             <a:avLst/>
           </a:prstGeom>
           <a:solidFill>
-            <a:srgbClr val="E08A3C"/>
+            <a:srgbClr val="5BC88A"/>
           </a:solidFill>
           <a:ln>
             <a:noFill/>
@@ -13971,7 +13971,7 @@
                 </a:solidFill>
                 <a:latin typeface="Calibri"/>
               </a:rPr>
-              <a:t>Why shadow</a:t>
+              <a:t>Why it's the go-forward</a:t>
             </a:r>
           </a:p>
         </p:txBody>
@@ -14006,10 +14006,10 @@
                 </a:solidFill>
                 <a:latin typeface="Calibri"/>
               </a:rPr>
-              <a:t>Runs capture-only — does NOT inject.
-A STRATUS bug can't degrade the agents.
-TDAI stays authoritative during the dual-run.
-Tap tails TDAI L0 → STRATUS /stream/add.</a:t>
+              <a:t>Clean-room provenance (no carried-over code).
+Same tier semantics as TDAI — drop-in upgrade path.
+Becoming the primary memory provider; TDAI is the predecessor being migrated from.
+Dual-run during cutover keeps risk low.</a:t>
             </a:r>
           </a:p>
         </p:txBody>
@@ -14040,11 +14040,11 @@
             <a:r>
               <a:rPr sz="1600" b="1" i="0">
                 <a:solidFill>
-                  <a:srgbClr val="E08A3C"/>
+                  <a:srgbClr val="5BC88A"/>
                 </a:solidFill>
                 <a:latin typeface="Calibri"/>
               </a:rPr>
-              <a:t>Safe by design:  </a:t>
+              <a:t>Cutover model:  </a:t>
             </a:r>
             <a:r>
               <a:rPr sz="1600" b="0" i="0">
@@ -14053,7 +14053,7 @@
                 </a:solidFill>
                 <a:latin typeface="Calibri"/>
               </a:rPr>
-              <a:t>shadow now, promote to live later by flipping the memory provider — no risky big-bang cutover.</a:t>
+              <a:t>run both engines side-by-side, then flip the memory provider to Falda — no risky big-bang switch.</a:t>
             </a:r>
           </a:p>
         </p:txBody>
@@ -14088,7 +14088,7 @@
                 </a:solidFill>
                 <a:latin typeface="Consolas"/>
               </a:rPr>
-              <a:t>Agent memory + cross-agent stack · TDAI / STRATUS · Sibline · UMP</a:t>
+              <a:t>Agent memory + cross-agent stack · TDAI / Falda · Sibline · UMP</a:t>
             </a:r>
           </a:p>
         </p:txBody>
@@ -14663,7 +14663,7 @@
                 </a:solidFill>
                 <a:latin typeface="Consolas"/>
               </a:rPr>
-              <a:t>Agent memory + cross-agent stack · TDAI / STRATUS · Sibline · UMP</a:t>
+              <a:t>Agent memory + cross-agent stack · TDAI / Falda · Sibline · UMP</a:t>
             </a:r>
           </a:p>
         </p:txBody>
@@ -14838,7 +14838,7 @@
                 </a:solidFill>
                 <a:latin typeface="Calibri"/>
               </a:rPr>
-              <a:t>Authoritative vs. shared vs. shadow</a:t>
+              <a:t>Primary vs. shared vs. legacy</a:t>
             </a:r>
           </a:p>
         </p:txBody>
@@ -14961,7 +14961,7 @@
                 </a:solidFill>
                 <a:latin typeface="Calibri"/>
               </a:rPr>
-              <a:t>AUTHORITATIVE</a:t>
+              <a:t>PRIMARY</a:t>
             </a:r>
           </a:p>
         </p:txBody>
@@ -14996,7 +14996,7 @@
                 </a:solidFill>
                 <a:latin typeface="Calibri"/>
               </a:rPr>
-              <a:t>injects into every turn</a:t>
+              <a:t>go-forward recall path</a:t>
             </a:r>
           </a:p>
         </p:txBody>
@@ -15051,7 +15051,7 @@
                 </a:solidFill>
                 <a:latin typeface="Calibri"/>
               </a:rPr>
-              <a:t>•  TDAI (L0→L3)</a:t>
+              <a:t>•  Falda (T0→T3)</a:t>
             </a:r>
           </a:p>
         </p:txBody>
@@ -15387,7 +15387,7 @@
                 </a:solidFill>
                 <a:latin typeface="Calibri"/>
               </a:rPr>
-              <a:t>SHADOW</a:t>
+              <a:t>LEGACY</a:t>
             </a:r>
           </a:p>
         </p:txBody>
@@ -15422,7 +15422,7 @@
                 </a:solidFill>
                 <a:latin typeface="Calibri"/>
               </a:rPr>
-              <a:t>captures, never injects</a:t>
+              <a:t>migrating from</a:t>
             </a:r>
           </a:p>
         </p:txBody>
@@ -15461,7 +15461,7 @@
                 </a:solidFill>
                 <a:latin typeface="Calibri"/>
               </a:rPr>
-              <a:t>•  STRATUS (T0→T3)</a:t>
+              <a:t>•  TDAI (L0→L3)</a:t>
             </a:r>
           </a:p>
         </p:txBody>
@@ -15505,7 +15505,7 @@
                 </a:solidFill>
                 <a:latin typeface="Calibri"/>
               </a:rPr>
-              <a:t>only authoritative systems touch the live recall path; shadow + shared are isolated from it.</a:t>
+              <a:t>only the primary path touches live recall; shared tiers are read on demand and the legacy engine is being phased out.</a:t>
             </a:r>
           </a:p>
         </p:txBody>
@@ -15540,7 +15540,7 @@
                 </a:solidFill>
                 <a:latin typeface="Consolas"/>
               </a:rPr>
-              <a:t>Agent memory + cross-agent stack · TDAI / STRATUS · Sibline · UMP</a:t>
+              <a:t>Agent memory + cross-agent stack · TDAI / Falda · Sibline · UMP</a:t>
             </a:r>
           </a:p>
         </p:txBody>
@@ -16370,7 +16370,7 @@
                 </a:solidFill>
                 <a:latin typeface="Consolas"/>
               </a:rPr>
-              <a:t>Agent memory + cross-agent stack · TDAI / STRATUS · Sibline · UMP</a:t>
+              <a:t>Agent memory + cross-agent stack · TDAI / Falda · Sibline · UMP</a:t>
             </a:r>
           </a:p>
         </p:txBody>

</xml_diff>